<commit_message>
-GET STUDENTS USERNAMES FROM EXCEL TO POPULATE A GROUP
</commit_message>
<xml_diff>
--- a/ExaminerB/.appCatalog/ExaminerB notes 1404.pptx
+++ b/ExaminerB/.appCatalog/ExaminerB notes 1404.pptx
@@ -280,7 +280,7 @@
             </a:pPr>
             <a:fld id="{BCC18F51-09EC-435C-A3BA-64A766E099C0}" type="datetimeFigureOut">
               <a:rPr lang="fa-IR"/>
-              <a:t>08/02/1448</a:t>
+              <a:t>16/04/1448</a:t>
             </a:fld>
             <a:endParaRPr/>
           </a:p>
@@ -459,7 +459,7 @@
             </a:pPr>
             <a:fld id="{BCC18F51-09EC-435C-A3BA-64A766E099C0}" type="datetimeFigureOut">
               <a:rPr lang="fa-IR"/>
-              <a:t>08/02/1448</a:t>
+              <a:t>16/04/1448</a:t>
             </a:fld>
             <a:endParaRPr/>
           </a:p>
@@ -648,7 +648,7 @@
             </a:pPr>
             <a:fld id="{BCC18F51-09EC-435C-A3BA-64A766E099C0}" type="datetimeFigureOut">
               <a:rPr lang="fa-IR"/>
-              <a:t>08/02/1448</a:t>
+              <a:t>16/04/1448</a:t>
             </a:fld>
             <a:endParaRPr/>
           </a:p>
@@ -827,7 +827,7 @@
             </a:pPr>
             <a:fld id="{BCC18F51-09EC-435C-A3BA-64A766E099C0}" type="datetimeFigureOut">
               <a:rPr lang="fa-IR"/>
-              <a:t>08/02/1448</a:t>
+              <a:t>16/04/1448</a:t>
             </a:fld>
             <a:endParaRPr/>
           </a:p>
@@ -1079,7 +1079,7 @@
             </a:pPr>
             <a:fld id="{BCC18F51-09EC-435C-A3BA-64A766E099C0}" type="datetimeFigureOut">
               <a:rPr lang="fa-IR"/>
-              <a:t>08/02/1448</a:t>
+              <a:t>16/04/1448</a:t>
             </a:fld>
             <a:endParaRPr/>
           </a:p>
@@ -1324,7 +1324,7 @@
             </a:pPr>
             <a:fld id="{BCC18F51-09EC-435C-A3BA-64A766E099C0}" type="datetimeFigureOut">
               <a:rPr lang="fa-IR"/>
-              <a:t>08/02/1448</a:t>
+              <a:t>16/04/1448</a:t>
             </a:fld>
             <a:endParaRPr/>
           </a:p>
@@ -1706,7 +1706,7 @@
             </a:pPr>
             <a:fld id="{BCC18F51-09EC-435C-A3BA-64A766E099C0}" type="datetimeFigureOut">
               <a:rPr lang="fa-IR"/>
-              <a:t>08/02/1448</a:t>
+              <a:t>16/04/1448</a:t>
             </a:fld>
             <a:endParaRPr/>
           </a:p>
@@ -1829,7 +1829,7 @@
             </a:pPr>
             <a:fld id="{BCC18F51-09EC-435C-A3BA-64A766E099C0}" type="datetimeFigureOut">
               <a:rPr lang="fa-IR"/>
-              <a:t>08/02/1448</a:t>
+              <a:t>16/04/1448</a:t>
             </a:fld>
             <a:endParaRPr/>
           </a:p>
@@ -1928,7 +1928,7 @@
             </a:pPr>
             <a:fld id="{BCC18F51-09EC-435C-A3BA-64A766E099C0}" type="datetimeFigureOut">
               <a:rPr lang="fa-IR"/>
-              <a:t>08/02/1448</a:t>
+              <a:t>16/04/1448</a:t>
             </a:fld>
             <a:endParaRPr/>
           </a:p>
@@ -2215,7 +2215,7 @@
             </a:pPr>
             <a:fld id="{BCC18F51-09EC-435C-A3BA-64A766E099C0}" type="datetimeFigureOut">
               <a:rPr lang="fa-IR"/>
-              <a:t>08/02/1448</a:t>
+              <a:t>16/04/1448</a:t>
             </a:fld>
             <a:endParaRPr/>
           </a:p>
@@ -2479,7 +2479,7 @@
             </a:pPr>
             <a:fld id="{BCC18F51-09EC-435C-A3BA-64A766E099C0}" type="datetimeFigureOut">
               <a:rPr lang="fa-IR"/>
-              <a:t>08/02/1448</a:t>
+              <a:t>16/04/1448</a:t>
             </a:fld>
             <a:endParaRPr/>
           </a:p>
@@ -2701,7 +2701,7 @@
             </a:pPr>
             <a:fld id="{BCC18F51-09EC-435C-A3BA-64A766E099C0}" type="datetimeFigureOut">
               <a:rPr lang="fa-IR"/>
-              <a:t>08/02/1448</a:t>
+              <a:t>16/04/1448</a:t>
             </a:fld>
             <a:endParaRPr/>
           </a:p>
@@ -6669,8 +6669,8 @@
         </p:nvSpPr>
         <p:spPr bwMode="auto">
           <a:xfrm>
-            <a:off x="2433261" y="5434973"/>
-            <a:ext cx="1182038" cy="900550"/>
+            <a:off x="2433261" y="5434972"/>
+            <a:ext cx="1182038" cy="1055015"/>
           </a:xfrm>
           <a:prstGeom prst="roundRect">
             <a:avLst>
@@ -6788,6 +6788,41 @@
                 <a:cs typeface="Segoe UI" panose="020B0502040204020203" pitchFamily="34" charset="0"/>
               </a:rPr>
               <a:t>UserId</a:t>
+            </a:r>
+          </a:p>
+          <a:p>
+            <a:pPr rtl="0">
+              <a:defRPr/>
+            </a:pPr>
+            <a:r>
+              <a:rPr lang="en-US" sz="853">
+                <a:solidFill>
+                  <a:schemeClr val="tx1"/>
+                </a:solidFill>
+                <a:latin typeface="Segoe UI" panose="020B0502040204020203" pitchFamily="34" charset="0"/>
+                <a:cs typeface="Segoe UI" panose="020B0502040204020203" pitchFamily="34" charset="0"/>
+              </a:rPr>
+              <a:t>Group</a:t>
+            </a:r>
+            <a:r>
+              <a:rPr lang="en-US" sz="853">
+                <a:solidFill>
+                  <a:srgbClr val="C00000"/>
+                </a:solidFill>
+                <a:latin typeface="Segoe UI" panose="020B0502040204020203" pitchFamily="34" charset="0"/>
+                <a:cs typeface="Segoe UI" panose="020B0502040204020203" pitchFamily="34" charset="0"/>
+              </a:rPr>
+              <a:t>Tags   </a:t>
+            </a:r>
+            <a:r>
+              <a:rPr lang="en-US" sz="600">
+                <a:solidFill>
+                  <a:srgbClr val="C00000"/>
+                </a:solidFill>
+                <a:latin typeface="Segoe UI" panose="020B0502040204020203" pitchFamily="34" charset="0"/>
+                <a:cs typeface="Segoe UI" panose="020B0502040204020203" pitchFamily="34" charset="0"/>
+              </a:rPr>
+              <a:t>1: act</a:t>
             </a:r>
           </a:p>
         </p:txBody>
@@ -8216,7 +8251,7 @@
         <p:spPr bwMode="auto">
           <a:xfrm>
             <a:off x="2931927" y="4398309"/>
-            <a:ext cx="1467637" cy="1268300"/>
+            <a:ext cx="1467637" cy="1292682"/>
           </a:xfrm>
           <a:prstGeom prst="roundRect">
             <a:avLst>
@@ -8365,7 +8400,7 @@
           <a:p>
             <a:pPr rtl="0"/>
             <a:r>
-              <a:rPr lang="en-US" sz="500">
+              <a:rPr lang="en-US" sz="600">
                 <a:solidFill>
                   <a:srgbClr val="C00000"/>
                 </a:solidFill>

</xml_diff>

<commit_message>
- Tags  for messages and groups
show all/active groups
show all/active messages
</commit_message>
<xml_diff>
--- a/ExaminerB/.appCatalog/ExaminerB notes 1404.pptx
+++ b/ExaminerB/.appCatalog/ExaminerB notes 1404.pptx
@@ -280,7 +280,7 @@
             </a:pPr>
             <a:fld id="{BCC18F51-09EC-435C-A3BA-64A766E099C0}" type="datetimeFigureOut">
               <a:rPr lang="fa-IR"/>
-              <a:t>16/04/1448</a:t>
+              <a:t>17/04/1448</a:t>
             </a:fld>
             <a:endParaRPr/>
           </a:p>
@@ -459,7 +459,7 @@
             </a:pPr>
             <a:fld id="{BCC18F51-09EC-435C-A3BA-64A766E099C0}" type="datetimeFigureOut">
               <a:rPr lang="fa-IR"/>
-              <a:t>16/04/1448</a:t>
+              <a:t>17/04/1448</a:t>
             </a:fld>
             <a:endParaRPr/>
           </a:p>
@@ -648,7 +648,7 @@
             </a:pPr>
             <a:fld id="{BCC18F51-09EC-435C-A3BA-64A766E099C0}" type="datetimeFigureOut">
               <a:rPr lang="fa-IR"/>
-              <a:t>16/04/1448</a:t>
+              <a:t>17/04/1448</a:t>
             </a:fld>
             <a:endParaRPr/>
           </a:p>
@@ -827,7 +827,7 @@
             </a:pPr>
             <a:fld id="{BCC18F51-09EC-435C-A3BA-64A766E099C0}" type="datetimeFigureOut">
               <a:rPr lang="fa-IR"/>
-              <a:t>16/04/1448</a:t>
+              <a:t>17/04/1448</a:t>
             </a:fld>
             <a:endParaRPr/>
           </a:p>
@@ -1079,7 +1079,7 @@
             </a:pPr>
             <a:fld id="{BCC18F51-09EC-435C-A3BA-64A766E099C0}" type="datetimeFigureOut">
               <a:rPr lang="fa-IR"/>
-              <a:t>16/04/1448</a:t>
+              <a:t>17/04/1448</a:t>
             </a:fld>
             <a:endParaRPr/>
           </a:p>
@@ -1324,7 +1324,7 @@
             </a:pPr>
             <a:fld id="{BCC18F51-09EC-435C-A3BA-64A766E099C0}" type="datetimeFigureOut">
               <a:rPr lang="fa-IR"/>
-              <a:t>16/04/1448</a:t>
+              <a:t>17/04/1448</a:t>
             </a:fld>
             <a:endParaRPr/>
           </a:p>
@@ -1706,7 +1706,7 @@
             </a:pPr>
             <a:fld id="{BCC18F51-09EC-435C-A3BA-64A766E099C0}" type="datetimeFigureOut">
               <a:rPr lang="fa-IR"/>
-              <a:t>16/04/1448</a:t>
+              <a:t>17/04/1448</a:t>
             </a:fld>
             <a:endParaRPr/>
           </a:p>
@@ -1829,7 +1829,7 @@
             </a:pPr>
             <a:fld id="{BCC18F51-09EC-435C-A3BA-64A766E099C0}" type="datetimeFigureOut">
               <a:rPr lang="fa-IR"/>
-              <a:t>16/04/1448</a:t>
+              <a:t>17/04/1448</a:t>
             </a:fld>
             <a:endParaRPr/>
           </a:p>
@@ -1928,7 +1928,7 @@
             </a:pPr>
             <a:fld id="{BCC18F51-09EC-435C-A3BA-64A766E099C0}" type="datetimeFigureOut">
               <a:rPr lang="fa-IR"/>
-              <a:t>16/04/1448</a:t>
+              <a:t>17/04/1448</a:t>
             </a:fld>
             <a:endParaRPr/>
           </a:p>
@@ -2215,7 +2215,7 @@
             </a:pPr>
             <a:fld id="{BCC18F51-09EC-435C-A3BA-64A766E099C0}" type="datetimeFigureOut">
               <a:rPr lang="fa-IR"/>
-              <a:t>16/04/1448</a:t>
+              <a:t>17/04/1448</a:t>
             </a:fld>
             <a:endParaRPr/>
           </a:p>
@@ -2479,7 +2479,7 @@
             </a:pPr>
             <a:fld id="{BCC18F51-09EC-435C-A3BA-64A766E099C0}" type="datetimeFigureOut">
               <a:rPr lang="fa-IR"/>
-              <a:t>16/04/1448</a:t>
+              <a:t>17/04/1448</a:t>
             </a:fld>
             <a:endParaRPr/>
           </a:p>
@@ -2701,7 +2701,7 @@
             </a:pPr>
             <a:fld id="{BCC18F51-09EC-435C-A3BA-64A766E099C0}" type="datetimeFigureOut">
               <a:rPr lang="fa-IR"/>
-              <a:t>16/04/1448</a:t>
+              <a:t>17/04/1448</a:t>
             </a:fld>
             <a:endParaRPr/>
           </a:p>
@@ -3333,10 +3333,7 @@
             </a:pathLst>
           </a:custGeom>
           <a:solidFill>
-            <a:schemeClr val="accent6">
-              <a:lumMod val="20000"/>
-              <a:lumOff val="80000"/>
-            </a:schemeClr>
+            <a:srgbClr val="EEF7E9"/>
           </a:solidFill>
           <a:ln w="28575">
             <a:noFill/>
@@ -5306,10 +5303,7 @@
             </a:pathLst>
           </a:custGeom>
           <a:solidFill>
-            <a:schemeClr val="accent1">
-              <a:lumMod val="20000"/>
-              <a:lumOff val="80000"/>
-            </a:schemeClr>
+            <a:srgbClr val="ECF3FA"/>
           </a:solidFill>
           <a:ln w="28575">
             <a:noFill/>
@@ -6047,10 +6041,7 @@
             </a:pathLst>
           </a:custGeom>
           <a:solidFill>
-            <a:schemeClr val="accent2">
-              <a:lumMod val="20000"/>
-              <a:lumOff val="80000"/>
-            </a:schemeClr>
+            <a:srgbClr val="FDF0E7"/>
           </a:solidFill>
           <a:ln w="28575">
             <a:noFill/>
@@ -6503,7 +6494,7 @@
         <p:spPr bwMode="auto">
           <a:xfrm>
             <a:off x="1641714" y="3131727"/>
-            <a:ext cx="1182039" cy="1199659"/>
+            <a:ext cx="1182039" cy="1404678"/>
           </a:xfrm>
           <a:prstGeom prst="roundRect">
             <a:avLst>
@@ -6652,6 +6643,48 @@
               </a:rPr>
               <a:t>MessageBody</a:t>
             </a:r>
+          </a:p>
+          <a:p>
+            <a:pPr rtl="0">
+              <a:defRPr/>
+            </a:pPr>
+            <a:r>
+              <a:rPr lang="en-US" sz="853">
+                <a:solidFill>
+                  <a:schemeClr val="tx1"/>
+                </a:solidFill>
+                <a:latin typeface="Segoe UI" panose="020B0502040204020203" pitchFamily="34" charset="0"/>
+                <a:cs typeface="Segoe UI" panose="020B0502040204020203" pitchFamily="34" charset="0"/>
+              </a:rPr>
+              <a:t>Message</a:t>
+            </a:r>
+            <a:r>
+              <a:rPr lang="en-US" sz="853">
+                <a:solidFill>
+                  <a:srgbClr val="C00000"/>
+                </a:solidFill>
+                <a:latin typeface="Segoe UI" panose="020B0502040204020203" pitchFamily="34" charset="0"/>
+                <a:cs typeface="Segoe UI" panose="020B0502040204020203" pitchFamily="34" charset="0"/>
+              </a:rPr>
+              <a:t>Tags   </a:t>
+            </a:r>
+            <a:r>
+              <a:rPr lang="en-US" sz="700">
+                <a:solidFill>
+                  <a:srgbClr val="C00000"/>
+                </a:solidFill>
+                <a:latin typeface="Segoe UI" panose="020B0502040204020203" pitchFamily="34" charset="0"/>
+                <a:cs typeface="Segoe UI" panose="020B0502040204020203" pitchFamily="34" charset="0"/>
+              </a:rPr>
+              <a:t>1: act</a:t>
+            </a:r>
+            <a:endParaRPr lang="en-US" sz="853">
+              <a:solidFill>
+                <a:srgbClr val="C00000"/>
+              </a:solidFill>
+              <a:latin typeface="Segoe UI" panose="020B0502040204020203" pitchFamily="34" charset="0"/>
+              <a:cs typeface="Segoe UI" panose="020B0502040204020203" pitchFamily="34" charset="0"/>
+            </a:endParaRPr>
           </a:p>
         </p:txBody>
       </p:sp>
@@ -8426,8 +8459,8 @@
         </p:nvSpPr>
         <p:spPr>
           <a:xfrm>
-            <a:off x="10063108" y="8393387"/>
-            <a:ext cx="1467068" cy="230832"/>
+            <a:off x="9576668" y="8352829"/>
+            <a:ext cx="1883849" cy="276999"/>
           </a:xfrm>
           <a:prstGeom prst="rect">
             <a:avLst/>
@@ -8442,7 +8475,7 @@
           <a:p>
             <a:pPr algn="l" rtl="0"/>
             <a:r>
-              <a:rPr lang="en-US" sz="900">
+              <a:rPr lang="en-US" sz="1200">
                 <a:solidFill>
                   <a:schemeClr val="accent5">
                     <a:lumMod val="75000"/>
@@ -8452,7 +8485,7 @@
               </a:rPr>
               <a:t>Majid SharifiTehrani</a:t>
             </a:r>
-            <a:endParaRPr lang="fa-IR" sz="900">
+            <a:endParaRPr lang="fa-IR" sz="1200">
               <a:solidFill>
                 <a:schemeClr val="accent5">
                   <a:lumMod val="75000"/>
@@ -11827,8 +11860,8 @@
         </p:blipFill>
         <p:spPr bwMode="auto">
           <a:xfrm>
-            <a:off x="10049013" y="7897994"/>
-            <a:ext cx="1414177" cy="525095"/>
+            <a:off x="9288636" y="23185"/>
+            <a:ext cx="2176215" cy="452230"/>
           </a:xfrm>
           <a:prstGeom prst="rect">
             <a:avLst/>

</xml_diff>

<commit_message>
- page T_Students Menu:Message with 4 submenus designed
</commit_message>
<xml_diff>
--- a/ExaminerB/.appCatalog/ExaminerB notes 1404.pptx
+++ b/ExaminerB/.appCatalog/ExaminerB notes 1404.pptx
@@ -280,7 +280,7 @@
             </a:pPr>
             <a:fld id="{BCC18F51-09EC-435C-A3BA-64A766E099C0}" type="datetimeFigureOut">
               <a:rPr lang="fa-IR"/>
-              <a:t>01/05/1448</a:t>
+              <a:t>03/05/1448</a:t>
             </a:fld>
             <a:endParaRPr/>
           </a:p>
@@ -459,7 +459,7 @@
             </a:pPr>
             <a:fld id="{BCC18F51-09EC-435C-A3BA-64A766E099C0}" type="datetimeFigureOut">
               <a:rPr lang="fa-IR"/>
-              <a:t>01/05/1448</a:t>
+              <a:t>03/05/1448</a:t>
             </a:fld>
             <a:endParaRPr/>
           </a:p>
@@ -648,7 +648,7 @@
             </a:pPr>
             <a:fld id="{BCC18F51-09EC-435C-A3BA-64A766E099C0}" type="datetimeFigureOut">
               <a:rPr lang="fa-IR"/>
-              <a:t>01/05/1448</a:t>
+              <a:t>03/05/1448</a:t>
             </a:fld>
             <a:endParaRPr/>
           </a:p>
@@ -827,7 +827,7 @@
             </a:pPr>
             <a:fld id="{BCC18F51-09EC-435C-A3BA-64A766E099C0}" type="datetimeFigureOut">
               <a:rPr lang="fa-IR"/>
-              <a:t>01/05/1448</a:t>
+              <a:t>03/05/1448</a:t>
             </a:fld>
             <a:endParaRPr/>
           </a:p>
@@ -1079,7 +1079,7 @@
             </a:pPr>
             <a:fld id="{BCC18F51-09EC-435C-A3BA-64A766E099C0}" type="datetimeFigureOut">
               <a:rPr lang="fa-IR"/>
-              <a:t>01/05/1448</a:t>
+              <a:t>03/05/1448</a:t>
             </a:fld>
             <a:endParaRPr/>
           </a:p>
@@ -1324,7 +1324,7 @@
             </a:pPr>
             <a:fld id="{BCC18F51-09EC-435C-A3BA-64A766E099C0}" type="datetimeFigureOut">
               <a:rPr lang="fa-IR"/>
-              <a:t>01/05/1448</a:t>
+              <a:t>03/05/1448</a:t>
             </a:fld>
             <a:endParaRPr/>
           </a:p>
@@ -1706,7 +1706,7 @@
             </a:pPr>
             <a:fld id="{BCC18F51-09EC-435C-A3BA-64A766E099C0}" type="datetimeFigureOut">
               <a:rPr lang="fa-IR"/>
-              <a:t>01/05/1448</a:t>
+              <a:t>03/05/1448</a:t>
             </a:fld>
             <a:endParaRPr/>
           </a:p>
@@ -1829,7 +1829,7 @@
             </a:pPr>
             <a:fld id="{BCC18F51-09EC-435C-A3BA-64A766E099C0}" type="datetimeFigureOut">
               <a:rPr lang="fa-IR"/>
-              <a:t>01/05/1448</a:t>
+              <a:t>03/05/1448</a:t>
             </a:fld>
             <a:endParaRPr/>
           </a:p>
@@ -1928,7 +1928,7 @@
             </a:pPr>
             <a:fld id="{BCC18F51-09EC-435C-A3BA-64A766E099C0}" type="datetimeFigureOut">
               <a:rPr lang="fa-IR"/>
-              <a:t>01/05/1448</a:t>
+              <a:t>03/05/1448</a:t>
             </a:fld>
             <a:endParaRPr/>
           </a:p>
@@ -2215,7 +2215,7 @@
             </a:pPr>
             <a:fld id="{BCC18F51-09EC-435C-A3BA-64A766E099C0}" type="datetimeFigureOut">
               <a:rPr lang="fa-IR"/>
-              <a:t>01/05/1448</a:t>
+              <a:t>03/05/1448</a:t>
             </a:fld>
             <a:endParaRPr/>
           </a:p>
@@ -2479,7 +2479,7 @@
             </a:pPr>
             <a:fld id="{BCC18F51-09EC-435C-A3BA-64A766E099C0}" type="datetimeFigureOut">
               <a:rPr lang="fa-IR"/>
-              <a:t>01/05/1448</a:t>
+              <a:t>03/05/1448</a:t>
             </a:fld>
             <a:endParaRPr/>
           </a:p>
@@ -2701,7 +2701,7 @@
             </a:pPr>
             <a:fld id="{BCC18F51-09EC-435C-A3BA-64A766E099C0}" type="datetimeFigureOut">
               <a:rPr lang="fa-IR"/>
-              <a:t>01/05/1448</a:t>
+              <a:t>03/05/1448</a:t>
             </a:fld>
             <a:endParaRPr/>
           </a:p>
@@ -6494,7 +6494,7 @@
         <p:spPr bwMode="auto">
           <a:xfrm>
             <a:off x="1641714" y="3131727"/>
-            <a:ext cx="1182039" cy="1404678"/>
+            <a:ext cx="1182039" cy="1793270"/>
           </a:xfrm>
           <a:prstGeom prst="roundRect">
             <a:avLst>
@@ -6666,8 +6666,13 @@
                 <a:latin typeface="Segoe UI" panose="020B0502040204020203" pitchFamily="34" charset="0"/>
                 <a:cs typeface="Segoe UI" panose="020B0502040204020203" pitchFamily="34" charset="0"/>
               </a:rPr>
-              <a:t>Tags   </a:t>
-            </a:r>
+              <a:t>Tags </a:t>
+            </a:r>
+          </a:p>
+          <a:p>
+            <a:pPr rtl="0">
+              <a:defRPr/>
+            </a:pPr>
             <a:r>
               <a:rPr lang="en-US" sz="700">
                 <a:solidFill>
@@ -6678,13 +6683,71 @@
               </a:rPr>
               <a:t>1: act</a:t>
             </a:r>
-            <a:endParaRPr lang="en-US" sz="853">
-              <a:solidFill>
-                <a:srgbClr val="C00000"/>
-              </a:solidFill>
-              <a:latin typeface="Segoe UI" panose="020B0502040204020203" pitchFamily="34" charset="0"/>
-              <a:cs typeface="Segoe UI" panose="020B0502040204020203" pitchFamily="34" charset="0"/>
-            </a:endParaRPr>
+          </a:p>
+          <a:p>
+            <a:pPr rtl="0">
+              <a:defRPr/>
+            </a:pPr>
+            <a:r>
+              <a:rPr lang="en-US" sz="800">
+                <a:solidFill>
+                  <a:srgbClr val="C00000"/>
+                </a:solidFill>
+                <a:latin typeface="Segoe UI" panose="020B0502040204020203" pitchFamily="34" charset="0"/>
+                <a:cs typeface="Segoe UI" panose="020B0502040204020203" pitchFamily="34" charset="0"/>
+              </a:rPr>
+              <a:t>2: IsSelected</a:t>
+            </a:r>
+          </a:p>
+          <a:p>
+            <a:pPr marL="0" marR="0" lvl="0" indent="0" defTabSz="914400" rtl="0" eaLnBrk="1" fontAlgn="auto" latinLnBrk="0" hangingPunct="1">
+              <a:lnSpc>
+                <a:spcPct val="100000"/>
+              </a:lnSpc>
+              <a:spcBef>
+                <a:spcPts val="0"/>
+              </a:spcBef>
+              <a:spcAft>
+                <a:spcPts val="0"/>
+              </a:spcAft>
+              <a:buClrTx/>
+              <a:buSzTx/>
+              <a:buFontTx/>
+              <a:buNone/>
+              <a:tabLst/>
+              <a:defRPr/>
+            </a:pPr>
+            <a:r>
+              <a:rPr kumimoji="0" lang="en-US" sz="800" b="0" i="0" u="none" strike="noStrike" kern="0" cap="none" spc="0" normalizeH="0" baseline="0" noProof="0">
+                <a:ln>
+                  <a:noFill/>
+                </a:ln>
+                <a:solidFill>
+                  <a:srgbClr val="C00000"/>
+                </a:solidFill>
+                <a:effectLst/>
+                <a:uLnTx/>
+                <a:uFillTx/>
+                <a:latin typeface="Segoe UI" panose="020B0502040204020203" pitchFamily="34" charset="0"/>
+                <a:cs typeface="Segoe UI" panose="020B0502040204020203" pitchFamily="34" charset="0"/>
+              </a:rPr>
+              <a:t>4: -</a:t>
+            </a:r>
+          </a:p>
+          <a:p>
+            <a:pPr rtl="0">
+              <a:defRPr/>
+            </a:pPr>
+            <a:r>
+              <a:rPr lang="en-US" sz="800">
+                <a:solidFill>
+                  <a:srgbClr val="C00000"/>
+                </a:solidFill>
+                <a:latin typeface="Segoe UI" panose="020B0502040204020203" pitchFamily="34" charset="0"/>
+                <a:cs typeface="Segoe UI" panose="020B0502040204020203" pitchFamily="34" charset="0"/>
+              </a:rPr>
+              <a:t>8: -</a:t>
+            </a:r>
           </a:p>
         </p:txBody>
       </p:sp>

</xml_diff>

<commit_message>
-games added to S_Student page -guide for T_Courses page
</commit_message>
<xml_diff>
--- a/ExaminerB/.appCatalog/ExaminerB notes 1404.pptx
+++ b/ExaminerB/.appCatalog/ExaminerB notes 1404.pptx
@@ -5,12 +5,13 @@
     <p:sldMasterId id="2147483648" r:id="rId1"/>
   </p:sldMasterIdLst>
   <p:notesMasterIdLst>
-    <p:notesMasterId r:id="rId5"/>
+    <p:notesMasterId r:id="rId6"/>
   </p:notesMasterIdLst>
   <p:sldIdLst>
     <p:sldId id="262" r:id="rId2"/>
     <p:sldId id="263" r:id="rId3"/>
-    <p:sldId id="264" r:id="rId4"/>
+    <p:sldId id="265" r:id="rId4"/>
+    <p:sldId id="264" r:id="rId5"/>
   </p:sldIdLst>
   <p:sldSz cx="9906000" cy="6858000" type="A4"/>
   <p:notesSz cx="6645275" cy="9777413"/>
@@ -280,7 +281,7 @@
             </a:pPr>
             <a:fld id="{BCC18F51-09EC-435C-A3BA-64A766E099C0}" type="datetimeFigureOut">
               <a:rPr lang="fa-IR"/>
-              <a:t>16/05/1448</a:t>
+              <a:t>17/05/1448</a:t>
             </a:fld>
             <a:endParaRPr/>
           </a:p>
@@ -459,7 +460,7 @@
             </a:pPr>
             <a:fld id="{BCC18F51-09EC-435C-A3BA-64A766E099C0}" type="datetimeFigureOut">
               <a:rPr lang="fa-IR"/>
-              <a:t>16/05/1448</a:t>
+              <a:t>17/05/1448</a:t>
             </a:fld>
             <a:endParaRPr/>
           </a:p>
@@ -648,7 +649,7 @@
             </a:pPr>
             <a:fld id="{BCC18F51-09EC-435C-A3BA-64A766E099C0}" type="datetimeFigureOut">
               <a:rPr lang="fa-IR"/>
-              <a:t>16/05/1448</a:t>
+              <a:t>17/05/1448</a:t>
             </a:fld>
             <a:endParaRPr/>
           </a:p>
@@ -827,7 +828,7 @@
             </a:pPr>
             <a:fld id="{BCC18F51-09EC-435C-A3BA-64A766E099C0}" type="datetimeFigureOut">
               <a:rPr lang="fa-IR"/>
-              <a:t>16/05/1448</a:t>
+              <a:t>17/05/1448</a:t>
             </a:fld>
             <a:endParaRPr/>
           </a:p>
@@ -1079,7 +1080,7 @@
             </a:pPr>
             <a:fld id="{BCC18F51-09EC-435C-A3BA-64A766E099C0}" type="datetimeFigureOut">
               <a:rPr lang="fa-IR"/>
-              <a:t>16/05/1448</a:t>
+              <a:t>17/05/1448</a:t>
             </a:fld>
             <a:endParaRPr/>
           </a:p>
@@ -1324,7 +1325,7 @@
             </a:pPr>
             <a:fld id="{BCC18F51-09EC-435C-A3BA-64A766E099C0}" type="datetimeFigureOut">
               <a:rPr lang="fa-IR"/>
-              <a:t>16/05/1448</a:t>
+              <a:t>17/05/1448</a:t>
             </a:fld>
             <a:endParaRPr/>
           </a:p>
@@ -1706,7 +1707,7 @@
             </a:pPr>
             <a:fld id="{BCC18F51-09EC-435C-A3BA-64A766E099C0}" type="datetimeFigureOut">
               <a:rPr lang="fa-IR"/>
-              <a:t>16/05/1448</a:t>
+              <a:t>17/05/1448</a:t>
             </a:fld>
             <a:endParaRPr/>
           </a:p>
@@ -1829,7 +1830,7 @@
             </a:pPr>
             <a:fld id="{BCC18F51-09EC-435C-A3BA-64A766E099C0}" type="datetimeFigureOut">
               <a:rPr lang="fa-IR"/>
-              <a:t>16/05/1448</a:t>
+              <a:t>17/05/1448</a:t>
             </a:fld>
             <a:endParaRPr/>
           </a:p>
@@ -1928,7 +1929,7 @@
             </a:pPr>
             <a:fld id="{BCC18F51-09EC-435C-A3BA-64A766E099C0}" type="datetimeFigureOut">
               <a:rPr lang="fa-IR"/>
-              <a:t>16/05/1448</a:t>
+              <a:t>17/05/1448</a:t>
             </a:fld>
             <a:endParaRPr/>
           </a:p>
@@ -2215,7 +2216,7 @@
             </a:pPr>
             <a:fld id="{BCC18F51-09EC-435C-A3BA-64A766E099C0}" type="datetimeFigureOut">
               <a:rPr lang="fa-IR"/>
-              <a:t>16/05/1448</a:t>
+              <a:t>17/05/1448</a:t>
             </a:fld>
             <a:endParaRPr/>
           </a:p>
@@ -2479,7 +2480,7 @@
             </a:pPr>
             <a:fld id="{BCC18F51-09EC-435C-A3BA-64A766E099C0}" type="datetimeFigureOut">
               <a:rPr lang="fa-IR"/>
-              <a:t>16/05/1448</a:t>
+              <a:t>17/05/1448</a:t>
             </a:fld>
             <a:endParaRPr/>
           </a:p>
@@ -2701,7 +2702,7 @@
             </a:pPr>
             <a:fld id="{BCC18F51-09EC-435C-A3BA-64A766E099C0}" type="datetimeFigureOut">
               <a:rPr lang="fa-IR"/>
-              <a:t>16/05/1448</a:t>
+              <a:t>17/05/1448</a:t>
             </a:fld>
             <a:endParaRPr/>
           </a:p>
@@ -11160,7 +11161,7 @@
                 <a:ea typeface="Dotum" panose="020B0600000101010101" pitchFamily="34" charset="-127"/>
                 <a:cs typeface="Biome Light" panose="020B0303030204020804" pitchFamily="34" charset="0"/>
               </a:rPr>
-              <a:t>aminer-Web / </a:t>
+              <a:t>aminer webapp / </a:t>
             </a:r>
             <a:r>
               <a:rPr lang="en-US" sz="8597">
@@ -11221,7 +11222,7 @@
                 <a:solidFill>
                   <a:schemeClr val="tx1"/>
                 </a:solidFill>
-                <a:latin typeface="Walbaum Display Light" panose="020F0502020204030204" pitchFamily="18" charset="0"/>
+                <a:latin typeface="Stormax Demo" pitchFamily="50" charset="0"/>
                 <a:ea typeface="Dotum" panose="020B0600000101010101" pitchFamily="34" charset="-127"/>
                 <a:cs typeface="Mj_Ebrahim" pitchFamily="2" charset="-78"/>
               </a:rPr>
@@ -11232,7 +11233,7 @@
                 <a:solidFill>
                   <a:srgbClr val="C00000"/>
                 </a:solidFill>
-                <a:latin typeface="Walbaum Display Light" panose="020F0502020204030204" pitchFamily="18" charset="0"/>
+                <a:latin typeface="Stormax Demo" pitchFamily="50" charset="0"/>
                 <a:ea typeface="Dotum" panose="020B0600000101010101" pitchFamily="34" charset="-127"/>
                 <a:cs typeface="Mj_Ebrahim" pitchFamily="2" charset="-78"/>
               </a:rPr>
@@ -11243,18 +11244,18 @@
                 <a:solidFill>
                   <a:schemeClr val="tx1"/>
                 </a:solidFill>
-                <a:latin typeface="Walbaum Display Light" panose="020F0502020204030204" pitchFamily="18" charset="0"/>
+                <a:latin typeface="Stormax Demo" pitchFamily="50" charset="0"/>
                 <a:ea typeface="Dotum" panose="020B0600000101010101" pitchFamily="34" charset="-127"/>
                 <a:cs typeface="Mj_Ebrahim" pitchFamily="2" charset="-78"/>
               </a:rPr>
-              <a:t>aminer - </a:t>
+              <a:t>aminer   </a:t>
             </a:r>
             <a:r>
               <a:rPr lang="en-US" sz="4923" i="1">
                 <a:solidFill>
                   <a:srgbClr val="C00000"/>
                 </a:solidFill>
-                <a:latin typeface="Walbaum Display Light" panose="020F0502020204030204" pitchFamily="18" charset="0"/>
+                <a:latin typeface="Stormax Demo" pitchFamily="50" charset="0"/>
                 <a:ea typeface="Dotum" panose="020B0600000101010101" pitchFamily="34" charset="-127"/>
                 <a:cs typeface="Mj_Ebrahim" pitchFamily="2" charset="-78"/>
               </a:rPr>
@@ -11265,7 +11266,7 @@
                 <a:solidFill>
                   <a:schemeClr val="tx1"/>
                 </a:solidFill>
-                <a:latin typeface="Walbaum Display Light" panose="020F0502020204030204" pitchFamily="18" charset="0"/>
+                <a:latin typeface="Stormax Demo" pitchFamily="50" charset="0"/>
                 <a:ea typeface="Dotum" panose="020B0600000101010101" pitchFamily="34" charset="-127"/>
                 <a:cs typeface="Mj_Ebrahim" pitchFamily="2" charset="-78"/>
               </a:rPr>
@@ -11375,6 +11376,281 @@
 </file>
 
 <file path=ppt/slides/slide3.xml><?xml version="1.0" encoding="utf-8"?>
+<p:sld xmlns:a="http://schemas.openxmlformats.org/drawingml/2006/main" xmlns:r="http://schemas.openxmlformats.org/officeDocument/2006/relationships" xmlns:p="http://schemas.openxmlformats.org/presentationml/2006/main">
+  <p:cSld>
+    <p:spTree>
+      <p:nvGrpSpPr>
+        <p:cNvPr id="1" name="">
+          <a:extLst>
+            <a:ext uri="{FF2B5EF4-FFF2-40B4-BE49-F238E27FC236}">
+              <a16:creationId xmlns:a16="http://schemas.microsoft.com/office/drawing/2014/main" id="{AB185D6D-CBF5-371E-4D03-1B60C8638E5B}"/>
+            </a:ext>
+          </a:extLst>
+        </p:cNvPr>
+        <p:cNvGrpSpPr/>
+        <p:nvPr/>
+      </p:nvGrpSpPr>
+      <p:grpSpPr>
+        <a:xfrm>
+          <a:off x="0" y="0"/>
+          <a:ext cx="0" cy="0"/>
+          <a:chOff x="0" y="0"/>
+          <a:chExt cx="0" cy="0"/>
+        </a:xfrm>
+      </p:grpSpPr>
+      <p:sp>
+        <p:nvSpPr>
+          <p:cNvPr id="20" name="TextBox 19">
+            <a:extLst>
+              <a:ext uri="{FF2B5EF4-FFF2-40B4-BE49-F238E27FC236}">
+                <a16:creationId xmlns:a16="http://schemas.microsoft.com/office/drawing/2014/main" id="{799EEBA2-CD4C-6B64-9D44-FA5656944A54}"/>
+              </a:ext>
+            </a:extLst>
+          </p:cNvPr>
+          <p:cNvSpPr txBox="1"/>
+          <p:nvPr/>
+        </p:nvSpPr>
+        <p:spPr>
+          <a:xfrm>
+            <a:off x="560512" y="5949280"/>
+            <a:ext cx="9144506" cy="584775"/>
+          </a:xfrm>
+          <a:prstGeom prst="rect">
+            <a:avLst/>
+          </a:prstGeom>
+          <a:noFill/>
+        </p:spPr>
+        <p:txBody>
+          <a:bodyPr wrap="square" rtlCol="0">
+            <a:spAutoFit/>
+          </a:bodyPr>
+          <a:lstStyle/>
+          <a:p>
+            <a:pPr algn="l" rtl="0"/>
+            <a:r>
+              <a:rPr lang="en-US" sz="3200">
+                <a:solidFill>
+                  <a:schemeClr val="tx1"/>
+                </a:solidFill>
+                <a:latin typeface="Takobe Demo" pitchFamily="2" charset="0"/>
+                <a:ea typeface="Dotum" panose="020B0600000101010101" pitchFamily="34" charset="-127"/>
+                <a:cs typeface="Biome Light" panose="020B0303030204020804" pitchFamily="34" charset="0"/>
+              </a:rPr>
+              <a:t>E</a:t>
+            </a:r>
+            <a:r>
+              <a:rPr lang="en-US" sz="3200">
+                <a:solidFill>
+                  <a:srgbClr val="C00000"/>
+                </a:solidFill>
+                <a:latin typeface="Takobe Demo" pitchFamily="2" charset="0"/>
+                <a:ea typeface="Dotum" panose="020B0600000101010101" pitchFamily="34" charset="-127"/>
+                <a:cs typeface="Biome Light" panose="020B0303030204020804" pitchFamily="34" charset="0"/>
+              </a:rPr>
+              <a:t>x</a:t>
+            </a:r>
+            <a:r>
+              <a:rPr lang="en-US" sz="3200">
+                <a:solidFill>
+                  <a:schemeClr val="tx1"/>
+                </a:solidFill>
+                <a:latin typeface="Takobe Demo" pitchFamily="2" charset="0"/>
+                <a:ea typeface="Dotum" panose="020B0600000101010101" pitchFamily="34" charset="-127"/>
+                <a:cs typeface="Biome Light" panose="020B0303030204020804" pitchFamily="34" charset="0"/>
+              </a:rPr>
+              <a:t>aminer webapp / </a:t>
+            </a:r>
+            <a:r>
+              <a:rPr lang="en-US" sz="3200">
+                <a:solidFill>
+                  <a:srgbClr val="C00000"/>
+                </a:solidFill>
+                <a:latin typeface="Takobe Demo" pitchFamily="2" charset="0"/>
+                <a:ea typeface="Dotum" panose="020B0600000101010101" pitchFamily="34" charset="-127"/>
+                <a:cs typeface="Biome Light" panose="020B0303030204020804" pitchFamily="34" charset="0"/>
+              </a:rPr>
+              <a:t>S</a:t>
+            </a:r>
+            <a:r>
+              <a:rPr lang="en-US" sz="3200">
+                <a:solidFill>
+                  <a:schemeClr val="tx1"/>
+                </a:solidFill>
+                <a:latin typeface="Takobe Demo" pitchFamily="2" charset="0"/>
+                <a:ea typeface="Dotum" panose="020B0600000101010101" pitchFamily="34" charset="-127"/>
+                <a:cs typeface="Biome Light" panose="020B0303030204020804" pitchFamily="34" charset="0"/>
+              </a:rPr>
+              <a:t>tudent</a:t>
+            </a:r>
+          </a:p>
+        </p:txBody>
+      </p:sp>
+      <p:sp>
+        <p:nvSpPr>
+          <p:cNvPr id="3" name="TextBox 2">
+            <a:extLst>
+              <a:ext uri="{FF2B5EF4-FFF2-40B4-BE49-F238E27FC236}">
+                <a16:creationId xmlns:a16="http://schemas.microsoft.com/office/drawing/2014/main" id="{BA542C89-B88B-B466-BB4E-C23D746331F0}"/>
+              </a:ext>
+            </a:extLst>
+          </p:cNvPr>
+          <p:cNvSpPr txBox="1"/>
+          <p:nvPr/>
+        </p:nvSpPr>
+        <p:spPr>
+          <a:xfrm>
+            <a:off x="380747" y="3136612"/>
+            <a:ext cx="8476452" cy="1200329"/>
+          </a:xfrm>
+          <a:prstGeom prst="rect">
+            <a:avLst/>
+          </a:prstGeom>
+          <a:noFill/>
+        </p:spPr>
+        <p:txBody>
+          <a:bodyPr wrap="square" rtlCol="0">
+            <a:spAutoFit/>
+          </a:bodyPr>
+          <a:lstStyle/>
+          <a:p>
+            <a:pPr algn="l" rtl="0"/>
+            <a:r>
+              <a:rPr lang="en-US" sz="7200" i="1">
+                <a:solidFill>
+                  <a:schemeClr val="tx1"/>
+                </a:solidFill>
+                <a:latin typeface="Brush Script MT" panose="03060802040406070304" pitchFamily="66" charset="0"/>
+                <a:ea typeface="Dotum" panose="020B0600000101010101" pitchFamily="34" charset="-127"/>
+                <a:cs typeface="Mj_Ebrahim" pitchFamily="2" charset="-78"/>
+              </a:rPr>
+              <a:t>e</a:t>
+            </a:r>
+            <a:r>
+              <a:rPr lang="en-US" sz="7200" i="1">
+                <a:solidFill>
+                  <a:srgbClr val="C00000"/>
+                </a:solidFill>
+                <a:latin typeface="Brush Script MT" panose="03060802040406070304" pitchFamily="66" charset="0"/>
+                <a:ea typeface="Dotum" panose="020B0600000101010101" pitchFamily="34" charset="-127"/>
+                <a:cs typeface="Mj_Ebrahim" pitchFamily="2" charset="-78"/>
+              </a:rPr>
+              <a:t>x</a:t>
+            </a:r>
+            <a:r>
+              <a:rPr lang="en-US" sz="7200" i="1">
+                <a:solidFill>
+                  <a:schemeClr val="tx1"/>
+                </a:solidFill>
+                <a:latin typeface="Brush Script MT" panose="03060802040406070304" pitchFamily="66" charset="0"/>
+                <a:ea typeface="Dotum" panose="020B0600000101010101" pitchFamily="34" charset="-127"/>
+                <a:cs typeface="Mj_Ebrahim" pitchFamily="2" charset="-78"/>
+              </a:rPr>
+              <a:t>aminer   </a:t>
+            </a:r>
+            <a:r>
+              <a:rPr lang="en-US" sz="7200" i="1">
+                <a:solidFill>
+                  <a:srgbClr val="C00000"/>
+                </a:solidFill>
+                <a:latin typeface="Brush Script MT" panose="03060802040406070304" pitchFamily="66" charset="0"/>
+                <a:ea typeface="Dotum" panose="020B0600000101010101" pitchFamily="34" charset="-127"/>
+                <a:cs typeface="Mj_Ebrahim" pitchFamily="2" charset="-78"/>
+              </a:rPr>
+              <a:t>s</a:t>
+            </a:r>
+            <a:r>
+              <a:rPr lang="en-US" sz="7200" i="1">
+                <a:solidFill>
+                  <a:schemeClr val="tx1"/>
+                </a:solidFill>
+                <a:latin typeface="Brush Script MT" panose="03060802040406070304" pitchFamily="66" charset="0"/>
+                <a:ea typeface="Dotum" panose="020B0600000101010101" pitchFamily="34" charset="-127"/>
+                <a:cs typeface="Mj_Ebrahim" pitchFamily="2" charset="-78"/>
+              </a:rPr>
+              <a:t>tudent</a:t>
+            </a:r>
+          </a:p>
+        </p:txBody>
+      </p:sp>
+      <p:sp>
+        <p:nvSpPr>
+          <p:cNvPr id="4" name="TextBox 3">
+            <a:extLst>
+              <a:ext uri="{FF2B5EF4-FFF2-40B4-BE49-F238E27FC236}">
+                <a16:creationId xmlns:a16="http://schemas.microsoft.com/office/drawing/2014/main" id="{BF7C7A78-3DCC-BCCD-976F-06B6E8D77426}"/>
+              </a:ext>
+            </a:extLst>
+          </p:cNvPr>
+          <p:cNvSpPr txBox="1"/>
+          <p:nvPr/>
+        </p:nvSpPr>
+        <p:spPr>
+          <a:xfrm>
+            <a:off x="391196" y="323945"/>
+            <a:ext cx="9144506" cy="584775"/>
+          </a:xfrm>
+          <a:prstGeom prst="rect">
+            <a:avLst/>
+          </a:prstGeom>
+          <a:noFill/>
+        </p:spPr>
+        <p:txBody>
+          <a:bodyPr wrap="square" rtlCol="0">
+            <a:spAutoFit/>
+          </a:bodyPr>
+          <a:lstStyle/>
+          <a:p>
+            <a:pPr algn="l" rtl="0"/>
+            <a:r>
+              <a:rPr lang="en-US" sz="3200">
+                <a:solidFill>
+                  <a:schemeClr val="tx1"/>
+                </a:solidFill>
+                <a:latin typeface="Sigokae Demo" panose="02000600000000000000" pitchFamily="2" charset="0"/>
+                <a:ea typeface="Dotum" panose="020B0600000101010101" pitchFamily="34" charset="-127"/>
+                <a:cs typeface="Biome Light" panose="020B0303030204020804" pitchFamily="34" charset="0"/>
+              </a:rPr>
+              <a:t>E</a:t>
+            </a:r>
+            <a:r>
+              <a:rPr lang="en-US" sz="3200">
+                <a:solidFill>
+                  <a:srgbClr val="C00000"/>
+                </a:solidFill>
+                <a:latin typeface="Sigokae Demo" panose="02000600000000000000" pitchFamily="2" charset="0"/>
+                <a:ea typeface="Dotum" panose="020B0600000101010101" pitchFamily="34" charset="-127"/>
+                <a:cs typeface="Biome Light" panose="020B0303030204020804" pitchFamily="34" charset="0"/>
+              </a:rPr>
+              <a:t>x</a:t>
+            </a:r>
+            <a:r>
+              <a:rPr lang="en-US" sz="3200">
+                <a:solidFill>
+                  <a:schemeClr val="tx1"/>
+                </a:solidFill>
+                <a:latin typeface="Sigokae Demo" panose="02000600000000000000" pitchFamily="2" charset="0"/>
+                <a:ea typeface="Dotum" panose="020B0600000101010101" pitchFamily="34" charset="-127"/>
+                <a:cs typeface="Biome Light" panose="020B0303030204020804" pitchFamily="34" charset="0"/>
+              </a:rPr>
+              <a:t>aminer</a:t>
+            </a:r>
+          </a:p>
+        </p:txBody>
+      </p:sp>
+    </p:spTree>
+    <p:extLst>
+      <p:ext uri="{BB962C8B-B14F-4D97-AF65-F5344CB8AC3E}">
+        <p14:creationId xmlns:p14="http://schemas.microsoft.com/office/powerpoint/2010/main" val="2765953567"/>
+      </p:ext>
+    </p:extLst>
+  </p:cSld>
+  <p:clrMapOvr>
+    <a:masterClrMapping/>
+  </p:clrMapOvr>
+</p:sld>
+</file>
+
+<file path=ppt/slides/slide4.xml><?xml version="1.0" encoding="utf-8"?>
 <p:sld xmlns:a="http://schemas.openxmlformats.org/drawingml/2006/main" xmlns:r="http://schemas.openxmlformats.org/officeDocument/2006/relationships" xmlns:p="http://schemas.openxmlformats.org/presentationml/2006/main">
   <p:cSld>
     <p:spTree>

</xml_diff>